<commit_message>
Regenerate ATMOS A-0 context diagram, letter-size print-ready IDEF0
ATMOS_A_MINUS_0_native.pptx: single-box A-0 context diagram on 11x8.5 landscape;
no text below 10pt; box contains only node 'A-0' + function name. Strict IDEF0
side semantics enforced via separate invisible connector ports: I1/I2 enter LEFT,
C1/C2/C3/I3 enter TOP (I3 routed as control), O1/O2/O3 leave RIGHT to boundary,
M1/M2/M3 enter BOTTOM. Orthogonal elbow connectors only (every arrow has a real
bend); arrowheads land on outside perimeters; no connector through the box. COWP
only in output data labels; no ATMOS decision authority implied.

Co-Authored-By: Claude Opus 4.8 <noreply@anthropic.com>
Claude-Session: https://claude.ai/code/session_01XC4dEHeBW19xbGRU29TYw2
</commit_message>
<xml_diff>
--- a/ATMOS_A_MINUS_0_native.pptx
+++ b/ATMOS_A_MINUS_0_native.pptx
@@ -7,7 +7,7 @@
   <p:sldIdLst>
     <p:sldId id="256" r:id="rId7"/>
   </p:sldIdLst>
-  <p:sldSz cx="12188952" cy="6858000" type="screen4x3"/>
+  <p:sldSz cx="10058400" cy="7772400" type="screen4x3"/>
   <p:notesSz cx="6858000" cy="9144000"/>
   <p:defaultTextStyle>
     <a:defPPr>
@@ -3090,14 +3090,58 @@
       <p:grpSpPr/>
       <p:sp>
         <p:nvSpPr>
-          <p:cNvPr id="2" name="TextBox 1"/>
+          <p:cNvPr id="2" name="Rectangle 1"/>
+          <p:cNvSpPr/>
+          <p:nvPr/>
+        </p:nvSpPr>
+        <p:spPr>
+          <a:xfrm>
+            <a:off x="274320" y="640080"/>
+            <a:ext cx="9509759" cy="6675120"/>
+          </a:xfrm>
+          <a:prstGeom prst="rect">
+            <a:avLst/>
+          </a:prstGeom>
+          <a:noFill/>
+          <a:ln w="12700">
+            <a:solidFill>
+              <a:srgbClr val="000000"/>
+            </a:solidFill>
+          </a:ln>
+          <a:effectLst/>
+        </p:spPr>
+        <p:style>
+          <a:lnRef idx="1">
+            <a:schemeClr val="accent1"/>
+          </a:lnRef>
+          <a:fillRef idx="3">
+            <a:schemeClr val="accent1"/>
+          </a:fillRef>
+          <a:effectRef idx="2">
+            <a:schemeClr val="accent1"/>
+          </a:effectRef>
+          <a:fontRef idx="minor">
+            <a:schemeClr val="lt1"/>
+          </a:fontRef>
+        </p:style>
+        <p:txBody>
+          <a:bodyPr rtlCol="0" anchor="ctr"/>
+          <a:lstStyle/>
+          <a:p>
+            <a:pPr algn="ctr"/>
+          </a:p>
+        </p:txBody>
+      </p:sp>
+      <p:sp>
+        <p:nvSpPr>
+          <p:cNvPr id="3" name="TextBox 2"/>
           <p:cNvSpPr txBox="1"/>
           <p:nvPr/>
         </p:nvSpPr>
         <p:spPr>
           <a:xfrm>
-            <a:off x="3200400" y="91440"/>
-            <a:ext cx="5788152" cy="365760"/>
+            <a:off x="274320" y="45720"/>
+            <a:ext cx="7406640" cy="246888"/>
           </a:xfrm>
           <a:prstGeom prst="rect">
             <a:avLst/>
@@ -3105,34 +3149,104 @@
           <a:noFill/>
         </p:spPr>
         <p:txBody>
-          <a:bodyPr wrap="square" anchor="t" lIns="25400" rIns="25400" tIns="12700" bIns="12700">
+          <a:bodyPr wrap="square" anchor="t" lIns="6350" rIns="6350" tIns="6350" bIns="6350">
             <a:spAutoFit/>
           </a:bodyPr>
           <a:lstStyle/>
           <a:p>
-            <a:pPr algn="ctr"/>
-            <a:r>
-              <a:rPr sz="1800" b="1">
+            <a:pPr algn="l"/>
+            <a:r>
+              <a:rPr sz="1200" b="1">
                 <a:solidFill>
                   <a:srgbClr val="000000"/>
                 </a:solidFill>
                 <a:latin typeface="Arial"/>
               </a:rPr>
-              <a:t>ATMOS Operational Architecture Context</a:t>
-            </a:r>
-          </a:p>
-        </p:txBody>
-      </p:sp>
-      <p:sp>
-        <p:nvSpPr>
-          <p:cNvPr id="3" name="Rectangle 2"/>
+              <a:t>A-0 — Conduct Air-Focused Weather Exploitation Operations</a:t>
+            </a:r>
+          </a:p>
+        </p:txBody>
+      </p:sp>
+      <p:sp>
+        <p:nvSpPr>
+          <p:cNvPr id="4" name="TextBox 3"/>
+          <p:cNvSpPr txBox="1"/>
+          <p:nvPr/>
+        </p:nvSpPr>
+        <p:spPr>
+          <a:xfrm>
+            <a:off x="7772400" y="54864"/>
+            <a:ext cx="2011680" cy="219456"/>
+          </a:xfrm>
+          <a:prstGeom prst="rect">
+            <a:avLst/>
+          </a:prstGeom>
+          <a:noFill/>
+        </p:spPr>
+        <p:txBody>
+          <a:bodyPr wrap="square" anchor="t" lIns="6350" rIns="6350" tIns="6350" bIns="6350">
+            <a:spAutoFit/>
+          </a:bodyPr>
+          <a:lstStyle/>
+          <a:p>
+            <a:pPr algn="r"/>
+            <a:r>
+              <a:rPr sz="1000" b="0">
+                <a:solidFill>
+                  <a:srgbClr val="000000"/>
+                </a:solidFill>
+                <a:latin typeface="Arial"/>
+              </a:rPr>
+              <a:t>Distribution Statement C</a:t>
+            </a:r>
+          </a:p>
+        </p:txBody>
+      </p:sp>
+      <p:sp>
+        <p:nvSpPr>
+          <p:cNvPr id="5" name="TextBox 4"/>
+          <p:cNvSpPr txBox="1"/>
+          <p:nvPr/>
+        </p:nvSpPr>
+        <p:spPr>
+          <a:xfrm>
+            <a:off x="8229600" y="6903720"/>
+            <a:ext cx="1463040" cy="228600"/>
+          </a:xfrm>
+          <a:prstGeom prst="rect">
+            <a:avLst/>
+          </a:prstGeom>
+          <a:noFill/>
+        </p:spPr>
+        <p:txBody>
+          <a:bodyPr wrap="square" anchor="t" lIns="6350" rIns="6350" tIns="6350" bIns="6350">
+            <a:spAutoFit/>
+          </a:bodyPr>
+          <a:lstStyle/>
+          <a:p>
+            <a:pPr algn="r"/>
+            <a:r>
+              <a:rPr sz="1000" b="1">
+                <a:solidFill>
+                  <a:srgbClr val="000000"/>
+                </a:solidFill>
+                <a:latin typeface="Arial"/>
+              </a:rPr>
+              <a:t>Node: A-0</a:t>
+            </a:r>
+          </a:p>
+        </p:txBody>
+      </p:sp>
+      <p:sp>
+        <p:nvSpPr>
+          <p:cNvPr id="6" name="Rectangle 5"/>
           <p:cNvSpPr/>
           <p:nvPr/>
         </p:nvSpPr>
         <p:spPr>
           <a:xfrm>
-            <a:off x="4453128" y="2606040"/>
-            <a:ext cx="3291840" cy="1645920"/>
+            <a:off x="3657600" y="2926080"/>
+            <a:ext cx="2743200" cy="1920239"/>
           </a:xfrm>
           <a:prstGeom prst="rect">
             <a:avLst/>
@@ -3140,7 +3254,7 @@
           <a:solidFill>
             <a:srgbClr val="FFFFFF"/>
           </a:solidFill>
-          <a:ln w="25400">
+          <a:ln w="22225">
             <a:solidFill>
               <a:srgbClr val="000000"/>
             </a:solidFill>
@@ -3166,41 +3280,6 @@
           <a:lstStyle/>
           <a:p>
             <a:pPr algn="ctr"/>
-            <a:r>
-              <a:rPr sz="1400" b="1">
-                <a:solidFill>
-                  <a:srgbClr val="000000"/>
-                </a:solidFill>
-                <a:latin typeface="Arial"/>
-              </a:rPr>
-              <a:t>Conduct Air-Focused Weather Exploitation Operations</a:t>
-            </a:r>
-          </a:p>
-        </p:txBody>
-      </p:sp>
-      <p:sp>
-        <p:nvSpPr>
-          <p:cNvPr id="4" name="TextBox 3"/>
-          <p:cNvSpPr txBox="1"/>
-          <p:nvPr/>
-        </p:nvSpPr>
-        <p:spPr>
-          <a:xfrm>
-            <a:off x="7059168" y="3922776"/>
-            <a:ext cx="594360" cy="274320"/>
-          </a:xfrm>
-          <a:prstGeom prst="rect">
-            <a:avLst/>
-          </a:prstGeom>
-          <a:noFill/>
-        </p:spPr>
-        <p:txBody>
-          <a:bodyPr wrap="square" anchor="b" lIns="25400" rIns="25400" tIns="12700" bIns="12700">
-            <a:spAutoFit/>
-          </a:bodyPr>
-          <a:lstStyle/>
-          <a:p>
-            <a:pPr algn="r"/>
             <a:r>
               <a:rPr sz="1200" b="1">
                 <a:solidFill>
@@ -3211,27 +3290,38 @@
               <a:t>A-0</a:t>
             </a:r>
           </a:p>
+          <a:p>
+            <a:pPr algn="ctr"/>
+            <a:r>
+              <a:rPr sz="1100" b="0">
+                <a:solidFill>
+                  <a:srgbClr val="000000"/>
+                </a:solidFill>
+                <a:latin typeface="Arial"/>
+              </a:rPr>
+              <a:t>Conduct Air-Focused Weather Exploitation Operations</a:t>
+            </a:r>
+          </a:p>
         </p:txBody>
       </p:sp>
       <p:cxnSp>
         <p:nvCxnSpPr>
-          <p:cNvPr id="5" name="Connector 4"/>
+          <p:cNvPr id="7" name="Connector 6"/>
           <p:cNvCxnSpPr/>
           <p:nvPr/>
         </p:nvCxnSpPr>
         <p:spPr>
           <a:xfrm>
-            <a:off x="457200" y="2880360"/>
-            <a:ext cx="3995928" cy="0"/>
+            <a:off x="274320" y="3154680"/>
+            <a:ext cx="1188720" cy="0"/>
           </a:xfrm>
           <a:prstGeom prst="line">
             <a:avLst/>
           </a:prstGeom>
-          <a:ln w="19050">
+          <a:ln w="15875">
             <a:solidFill>
               <a:srgbClr val="000000"/>
             </a:solidFill>
-            <a:tailEnd type="triangle" w="med" len="med"/>
           </a:ln>
         </p:spPr>
         <p:style>
@@ -3249,16 +3339,277 @@
           </a:fontRef>
         </p:style>
       </p:cxnSp>
-      <p:sp>
-        <p:nvSpPr>
-          <p:cNvPr id="6" name="TextBox 5"/>
+      <p:cxnSp>
+        <p:nvCxnSpPr>
+          <p:cNvPr id="8" name="Connector 7"/>
+          <p:cNvCxnSpPr/>
+          <p:nvPr/>
+        </p:nvCxnSpPr>
+        <p:spPr>
+          <a:xfrm>
+            <a:off x="1463040" y="3154680"/>
+            <a:ext cx="0" cy="228600"/>
+          </a:xfrm>
+          <a:prstGeom prst="line">
+            <a:avLst/>
+          </a:prstGeom>
+          <a:ln w="15875">
+            <a:solidFill>
+              <a:srgbClr val="000000"/>
+            </a:solidFill>
+          </a:ln>
+        </p:spPr>
+        <p:style>
+          <a:lnRef idx="2">
+            <a:schemeClr val="accent1"/>
+          </a:lnRef>
+          <a:fillRef idx="0">
+            <a:schemeClr val="accent1"/>
+          </a:fillRef>
+          <a:effectRef idx="1">
+            <a:schemeClr val="accent1"/>
+          </a:effectRef>
+          <a:fontRef idx="minor">
+            <a:schemeClr val="tx1"/>
+          </a:fontRef>
+        </p:style>
+      </p:cxnSp>
+      <p:cxnSp>
+        <p:nvCxnSpPr>
+          <p:cNvPr id="9" name="Connector 8"/>
+          <p:cNvCxnSpPr/>
+          <p:nvPr/>
+        </p:nvCxnSpPr>
+        <p:spPr>
+          <a:xfrm>
+            <a:off x="1463040" y="3383280"/>
+            <a:ext cx="2194560" cy="0"/>
+          </a:xfrm>
+          <a:prstGeom prst="line">
+            <a:avLst/>
+          </a:prstGeom>
+          <a:ln w="15875">
+            <a:solidFill>
+              <a:srgbClr val="000000"/>
+            </a:solidFill>
+            <a:tailEnd type="triangle" w="med" len="med"/>
+          </a:ln>
+        </p:spPr>
+        <p:style>
+          <a:lnRef idx="2">
+            <a:schemeClr val="accent1"/>
+          </a:lnRef>
+          <a:fillRef idx="0">
+            <a:schemeClr val="accent1"/>
+          </a:fillRef>
+          <a:effectRef idx="1">
+            <a:schemeClr val="accent1"/>
+          </a:effectRef>
+          <a:fontRef idx="minor">
+            <a:schemeClr val="tx1"/>
+          </a:fontRef>
+        </p:style>
+      </p:cxnSp>
+      <p:sp>
+        <p:nvSpPr>
+          <p:cNvPr id="10" name="Rectangle 9"/>
+          <p:cNvSpPr/>
+          <p:nvPr/>
+        </p:nvSpPr>
+        <p:spPr>
+          <a:xfrm>
+            <a:off x="3639312" y="3364992"/>
+            <a:ext cx="36576" cy="36576"/>
+          </a:xfrm>
+          <a:prstGeom prst="rect">
+            <a:avLst/>
+          </a:prstGeom>
+          <a:noFill/>
+          <a:ln>
+            <a:noFill/>
+          </a:ln>
+          <a:effectLst/>
+        </p:spPr>
+        <p:style>
+          <a:lnRef idx="1">
+            <a:schemeClr val="accent1"/>
+          </a:lnRef>
+          <a:fillRef idx="3">
+            <a:schemeClr val="accent1"/>
+          </a:fillRef>
+          <a:effectRef idx="2">
+            <a:schemeClr val="accent1"/>
+          </a:effectRef>
+          <a:fontRef idx="minor">
+            <a:schemeClr val="lt1"/>
+          </a:fontRef>
+        </p:style>
+        <p:txBody>
+          <a:bodyPr rtlCol="0" anchor="ctr"/>
+          <a:lstStyle/>
+          <a:p>
+            <a:pPr algn="ctr"/>
+          </a:p>
+        </p:txBody>
+      </p:sp>
+      <p:cxnSp>
+        <p:nvCxnSpPr>
+          <p:cNvPr id="11" name="Connector 10"/>
+          <p:cNvCxnSpPr/>
+          <p:nvPr/>
+        </p:nvCxnSpPr>
+        <p:spPr>
+          <a:xfrm>
+            <a:off x="274320" y="4617720"/>
+            <a:ext cx="1188720" cy="0"/>
+          </a:xfrm>
+          <a:prstGeom prst="line">
+            <a:avLst/>
+          </a:prstGeom>
+          <a:ln w="15875">
+            <a:solidFill>
+              <a:srgbClr val="000000"/>
+            </a:solidFill>
+          </a:ln>
+        </p:spPr>
+        <p:style>
+          <a:lnRef idx="2">
+            <a:schemeClr val="accent1"/>
+          </a:lnRef>
+          <a:fillRef idx="0">
+            <a:schemeClr val="accent1"/>
+          </a:fillRef>
+          <a:effectRef idx="1">
+            <a:schemeClr val="accent1"/>
+          </a:effectRef>
+          <a:fontRef idx="minor">
+            <a:schemeClr val="tx1"/>
+          </a:fontRef>
+        </p:style>
+      </p:cxnSp>
+      <p:cxnSp>
+        <p:nvCxnSpPr>
+          <p:cNvPr id="12" name="Connector 11"/>
+          <p:cNvCxnSpPr/>
+          <p:nvPr/>
+        </p:nvCxnSpPr>
+        <p:spPr>
+          <a:xfrm flipV="1">
+            <a:off x="1463040" y="4389120"/>
+            <a:ext cx="0" cy="228600"/>
+          </a:xfrm>
+          <a:prstGeom prst="line">
+            <a:avLst/>
+          </a:prstGeom>
+          <a:ln w="15875">
+            <a:solidFill>
+              <a:srgbClr val="000000"/>
+            </a:solidFill>
+          </a:ln>
+        </p:spPr>
+        <p:style>
+          <a:lnRef idx="2">
+            <a:schemeClr val="accent1"/>
+          </a:lnRef>
+          <a:fillRef idx="0">
+            <a:schemeClr val="accent1"/>
+          </a:fillRef>
+          <a:effectRef idx="1">
+            <a:schemeClr val="accent1"/>
+          </a:effectRef>
+          <a:fontRef idx="minor">
+            <a:schemeClr val="tx1"/>
+          </a:fontRef>
+        </p:style>
+      </p:cxnSp>
+      <p:cxnSp>
+        <p:nvCxnSpPr>
+          <p:cNvPr id="13" name="Connector 12"/>
+          <p:cNvCxnSpPr/>
+          <p:nvPr/>
+        </p:nvCxnSpPr>
+        <p:spPr>
+          <a:xfrm>
+            <a:off x="1463040" y="4389120"/>
+            <a:ext cx="2194560" cy="0"/>
+          </a:xfrm>
+          <a:prstGeom prst="line">
+            <a:avLst/>
+          </a:prstGeom>
+          <a:ln w="15875">
+            <a:solidFill>
+              <a:srgbClr val="000000"/>
+            </a:solidFill>
+            <a:tailEnd type="triangle" w="med" len="med"/>
+          </a:ln>
+        </p:spPr>
+        <p:style>
+          <a:lnRef idx="2">
+            <a:schemeClr val="accent1"/>
+          </a:lnRef>
+          <a:fillRef idx="0">
+            <a:schemeClr val="accent1"/>
+          </a:fillRef>
+          <a:effectRef idx="1">
+            <a:schemeClr val="accent1"/>
+          </a:effectRef>
+          <a:fontRef idx="minor">
+            <a:schemeClr val="tx1"/>
+          </a:fontRef>
+        </p:style>
+      </p:cxnSp>
+      <p:sp>
+        <p:nvSpPr>
+          <p:cNvPr id="14" name="Rectangle 13"/>
+          <p:cNvSpPr/>
+          <p:nvPr/>
+        </p:nvSpPr>
+        <p:spPr>
+          <a:xfrm>
+            <a:off x="3639312" y="4370832"/>
+            <a:ext cx="36576" cy="36576"/>
+          </a:xfrm>
+          <a:prstGeom prst="rect">
+            <a:avLst/>
+          </a:prstGeom>
+          <a:noFill/>
+          <a:ln>
+            <a:noFill/>
+          </a:ln>
+          <a:effectLst/>
+        </p:spPr>
+        <p:style>
+          <a:lnRef idx="1">
+            <a:schemeClr val="accent1"/>
+          </a:lnRef>
+          <a:fillRef idx="3">
+            <a:schemeClr val="accent1"/>
+          </a:fillRef>
+          <a:effectRef idx="2">
+            <a:schemeClr val="accent1"/>
+          </a:effectRef>
+          <a:fontRef idx="minor">
+            <a:schemeClr val="lt1"/>
+          </a:fontRef>
+        </p:style>
+        <p:txBody>
+          <a:bodyPr rtlCol="0" anchor="ctr"/>
+          <a:lstStyle/>
+          <a:p>
+            <a:pPr algn="ctr"/>
+          </a:p>
+        </p:txBody>
+      </p:sp>
+      <p:sp>
+        <p:nvSpPr>
+          <p:cNvPr id="15" name="TextBox 14"/>
           <p:cNvSpPr txBox="1"/>
           <p:nvPr/>
         </p:nvSpPr>
         <p:spPr>
           <a:xfrm>
-            <a:off x="502920" y="2606040"/>
-            <a:ext cx="3566160" cy="256032"/>
+            <a:off x="320040" y="2798064"/>
+            <a:ext cx="2743200" cy="292608"/>
           </a:xfrm>
           <a:prstGeom prst="rect">
             <a:avLst/>
@@ -3266,14 +3617,14 @@
           <a:noFill/>
         </p:spPr>
         <p:txBody>
-          <a:bodyPr wrap="square" anchor="t" lIns="25400" rIns="25400" tIns="12700" bIns="12700">
+          <a:bodyPr wrap="square" anchor="t" lIns="6350" rIns="6350" tIns="6350" bIns="6350">
             <a:spAutoFit/>
           </a:bodyPr>
           <a:lstStyle/>
           <a:p>
             <a:pPr algn="l"/>
             <a:r>
-              <a:rPr sz="900" b="0">
+              <a:rPr sz="1000" b="0">
                 <a:solidFill>
                   <a:srgbClr val="000000"/>
                 </a:solidFill>
@@ -3284,25 +3635,59 @@
           </a:p>
         </p:txBody>
       </p:sp>
+      <p:sp>
+        <p:nvSpPr>
+          <p:cNvPr id="16" name="TextBox 15"/>
+          <p:cNvSpPr txBox="1"/>
+          <p:nvPr/>
+        </p:nvSpPr>
+        <p:spPr>
+          <a:xfrm>
+            <a:off x="320040" y="4681728"/>
+            <a:ext cx="2743200" cy="292608"/>
+          </a:xfrm>
+          <a:prstGeom prst="rect">
+            <a:avLst/>
+          </a:prstGeom>
+          <a:noFill/>
+        </p:spPr>
+        <p:txBody>
+          <a:bodyPr wrap="square" anchor="t" lIns="6350" rIns="6350" tIns="6350" bIns="6350">
+            <a:spAutoFit/>
+          </a:bodyPr>
+          <a:lstStyle/>
+          <a:p>
+            <a:pPr algn="l"/>
+            <a:r>
+              <a:rPr sz="1000" b="0">
+                <a:solidFill>
+                  <a:srgbClr val="000000"/>
+                </a:solidFill>
+                <a:latin typeface="Arial"/>
+              </a:rPr>
+              <a:t>I2 Peer Platform Weather Observations</a:t>
+            </a:r>
+          </a:p>
+        </p:txBody>
+      </p:sp>
       <p:cxnSp>
         <p:nvCxnSpPr>
-          <p:cNvPr id="7" name="Connector 6"/>
+          <p:cNvPr id="17" name="Connector 16"/>
           <p:cNvCxnSpPr/>
           <p:nvPr/>
         </p:nvCxnSpPr>
         <p:spPr>
           <a:xfrm>
-            <a:off x="457200" y="3429000"/>
-            <a:ext cx="3995928" cy="0"/>
+            <a:off x="1828800" y="640080"/>
+            <a:ext cx="0" cy="594360"/>
           </a:xfrm>
           <a:prstGeom prst="line">
             <a:avLst/>
           </a:prstGeom>
-          <a:ln w="19050">
+          <a:ln w="15875">
             <a:solidFill>
               <a:srgbClr val="000000"/>
             </a:solidFill>
-            <a:tailEnd type="triangle" w="med" len="med"/>
           </a:ln>
         </p:spPr>
         <p:style>
@@ -3320,60 +3705,24 @@
           </a:fontRef>
         </p:style>
       </p:cxnSp>
-      <p:sp>
-        <p:nvSpPr>
-          <p:cNvPr id="8" name="TextBox 7"/>
-          <p:cNvSpPr txBox="1"/>
-          <p:nvPr/>
-        </p:nvSpPr>
-        <p:spPr>
-          <a:xfrm>
-            <a:off x="502920" y="3154680"/>
-            <a:ext cx="3566160" cy="256032"/>
-          </a:xfrm>
-          <a:prstGeom prst="rect">
-            <a:avLst/>
-          </a:prstGeom>
-          <a:noFill/>
-        </p:spPr>
-        <p:txBody>
-          <a:bodyPr wrap="square" anchor="t" lIns="25400" rIns="25400" tIns="12700" bIns="12700">
-            <a:spAutoFit/>
-          </a:bodyPr>
-          <a:lstStyle/>
-          <a:p>
-            <a:pPr algn="l"/>
-            <a:r>
-              <a:rPr sz="900" b="0">
-                <a:solidFill>
-                  <a:srgbClr val="000000"/>
-                </a:solidFill>
-                <a:latin typeface="Arial"/>
-              </a:rPr>
-              <a:t>I2 Peer Platform Weather Observations</a:t>
-            </a:r>
-          </a:p>
-        </p:txBody>
-      </p:sp>
       <p:cxnSp>
         <p:nvCxnSpPr>
-          <p:cNvPr id="9" name="Connector 8"/>
+          <p:cNvPr id="18" name="Connector 17"/>
           <p:cNvCxnSpPr/>
           <p:nvPr/>
         </p:nvCxnSpPr>
         <p:spPr>
           <a:xfrm>
-            <a:off x="457200" y="3977639"/>
-            <a:ext cx="3995928" cy="0"/>
+            <a:off x="1828800" y="1234440"/>
+            <a:ext cx="2240280" cy="0"/>
           </a:xfrm>
           <a:prstGeom prst="line">
             <a:avLst/>
           </a:prstGeom>
-          <a:ln w="19050">
+          <a:ln w="15875">
             <a:solidFill>
               <a:srgbClr val="000000"/>
             </a:solidFill>
-            <a:tailEnd type="triangle" w="med" len="med"/>
           </a:ln>
         </p:spPr>
         <p:style>
@@ -3391,16 +3740,538 @@
           </a:fontRef>
         </p:style>
       </p:cxnSp>
-      <p:sp>
-        <p:nvSpPr>
-          <p:cNvPr id="10" name="TextBox 9"/>
+      <p:cxnSp>
+        <p:nvCxnSpPr>
+          <p:cNvPr id="19" name="Connector 18"/>
+          <p:cNvCxnSpPr/>
+          <p:nvPr/>
+        </p:nvCxnSpPr>
+        <p:spPr>
+          <a:xfrm>
+            <a:off x="4069080" y="1234440"/>
+            <a:ext cx="0" cy="1691640"/>
+          </a:xfrm>
+          <a:prstGeom prst="line">
+            <a:avLst/>
+          </a:prstGeom>
+          <a:ln w="15875">
+            <a:solidFill>
+              <a:srgbClr val="000000"/>
+            </a:solidFill>
+            <a:tailEnd type="triangle" w="med" len="med"/>
+          </a:ln>
+        </p:spPr>
+        <p:style>
+          <a:lnRef idx="2">
+            <a:schemeClr val="accent1"/>
+          </a:lnRef>
+          <a:fillRef idx="0">
+            <a:schemeClr val="accent1"/>
+          </a:fillRef>
+          <a:effectRef idx="1">
+            <a:schemeClr val="accent1"/>
+          </a:effectRef>
+          <a:fontRef idx="minor">
+            <a:schemeClr val="tx1"/>
+          </a:fontRef>
+        </p:style>
+      </p:cxnSp>
+      <p:sp>
+        <p:nvSpPr>
+          <p:cNvPr id="20" name="Rectangle 19"/>
+          <p:cNvSpPr/>
+          <p:nvPr/>
+        </p:nvSpPr>
+        <p:spPr>
+          <a:xfrm>
+            <a:off x="4050792" y="2907792"/>
+            <a:ext cx="36576" cy="36576"/>
+          </a:xfrm>
+          <a:prstGeom prst="rect">
+            <a:avLst/>
+          </a:prstGeom>
+          <a:noFill/>
+          <a:ln>
+            <a:noFill/>
+          </a:ln>
+          <a:effectLst/>
+        </p:spPr>
+        <p:style>
+          <a:lnRef idx="1">
+            <a:schemeClr val="accent1"/>
+          </a:lnRef>
+          <a:fillRef idx="3">
+            <a:schemeClr val="accent1"/>
+          </a:fillRef>
+          <a:effectRef idx="2">
+            <a:schemeClr val="accent1"/>
+          </a:effectRef>
+          <a:fontRef idx="minor">
+            <a:schemeClr val="lt1"/>
+          </a:fontRef>
+        </p:style>
+        <p:txBody>
+          <a:bodyPr rtlCol="0" anchor="ctr"/>
+          <a:lstStyle/>
+          <a:p>
+            <a:pPr algn="ctr"/>
+          </a:p>
+        </p:txBody>
+      </p:sp>
+      <p:cxnSp>
+        <p:nvCxnSpPr>
+          <p:cNvPr id="21" name="Connector 20"/>
+          <p:cNvCxnSpPr/>
+          <p:nvPr/>
+        </p:nvCxnSpPr>
+        <p:spPr>
+          <a:xfrm>
+            <a:off x="3840480" y="640080"/>
+            <a:ext cx="0" cy="960120"/>
+          </a:xfrm>
+          <a:prstGeom prst="line">
+            <a:avLst/>
+          </a:prstGeom>
+          <a:ln w="15875">
+            <a:solidFill>
+              <a:srgbClr val="000000"/>
+            </a:solidFill>
+          </a:ln>
+        </p:spPr>
+        <p:style>
+          <a:lnRef idx="2">
+            <a:schemeClr val="accent1"/>
+          </a:lnRef>
+          <a:fillRef idx="0">
+            <a:schemeClr val="accent1"/>
+          </a:fillRef>
+          <a:effectRef idx="1">
+            <a:schemeClr val="accent1"/>
+          </a:effectRef>
+          <a:fontRef idx="minor">
+            <a:schemeClr val="tx1"/>
+          </a:fontRef>
+        </p:style>
+      </p:cxnSp>
+      <p:cxnSp>
+        <p:nvCxnSpPr>
+          <p:cNvPr id="22" name="Connector 21"/>
+          <p:cNvCxnSpPr/>
+          <p:nvPr/>
+        </p:nvCxnSpPr>
+        <p:spPr>
+          <a:xfrm>
+            <a:off x="3840480" y="1600200"/>
+            <a:ext cx="868680" cy="0"/>
+          </a:xfrm>
+          <a:prstGeom prst="line">
+            <a:avLst/>
+          </a:prstGeom>
+          <a:ln w="15875">
+            <a:solidFill>
+              <a:srgbClr val="000000"/>
+            </a:solidFill>
+          </a:ln>
+        </p:spPr>
+        <p:style>
+          <a:lnRef idx="2">
+            <a:schemeClr val="accent1"/>
+          </a:lnRef>
+          <a:fillRef idx="0">
+            <a:schemeClr val="accent1"/>
+          </a:fillRef>
+          <a:effectRef idx="1">
+            <a:schemeClr val="accent1"/>
+          </a:effectRef>
+          <a:fontRef idx="minor">
+            <a:schemeClr val="tx1"/>
+          </a:fontRef>
+        </p:style>
+      </p:cxnSp>
+      <p:cxnSp>
+        <p:nvCxnSpPr>
+          <p:cNvPr id="23" name="Connector 22"/>
+          <p:cNvCxnSpPr/>
+          <p:nvPr/>
+        </p:nvCxnSpPr>
+        <p:spPr>
+          <a:xfrm>
+            <a:off x="4709160" y="1600200"/>
+            <a:ext cx="0" cy="1325880"/>
+          </a:xfrm>
+          <a:prstGeom prst="line">
+            <a:avLst/>
+          </a:prstGeom>
+          <a:ln w="15875">
+            <a:solidFill>
+              <a:srgbClr val="000000"/>
+            </a:solidFill>
+            <a:tailEnd type="triangle" w="med" len="med"/>
+          </a:ln>
+        </p:spPr>
+        <p:style>
+          <a:lnRef idx="2">
+            <a:schemeClr val="accent1"/>
+          </a:lnRef>
+          <a:fillRef idx="0">
+            <a:schemeClr val="accent1"/>
+          </a:fillRef>
+          <a:effectRef idx="1">
+            <a:schemeClr val="accent1"/>
+          </a:effectRef>
+          <a:fontRef idx="minor">
+            <a:schemeClr val="tx1"/>
+          </a:fontRef>
+        </p:style>
+      </p:cxnSp>
+      <p:sp>
+        <p:nvSpPr>
+          <p:cNvPr id="24" name="Rectangle 23"/>
+          <p:cNvSpPr/>
+          <p:nvPr/>
+        </p:nvSpPr>
+        <p:spPr>
+          <a:xfrm>
+            <a:off x="4690872" y="2907792"/>
+            <a:ext cx="36576" cy="36576"/>
+          </a:xfrm>
+          <a:prstGeom prst="rect">
+            <a:avLst/>
+          </a:prstGeom>
+          <a:noFill/>
+          <a:ln>
+            <a:noFill/>
+          </a:ln>
+          <a:effectLst/>
+        </p:spPr>
+        <p:style>
+          <a:lnRef idx="1">
+            <a:schemeClr val="accent1"/>
+          </a:lnRef>
+          <a:fillRef idx="3">
+            <a:schemeClr val="accent1"/>
+          </a:fillRef>
+          <a:effectRef idx="2">
+            <a:schemeClr val="accent1"/>
+          </a:effectRef>
+          <a:fontRef idx="minor">
+            <a:schemeClr val="lt1"/>
+          </a:fontRef>
+        </p:style>
+        <p:txBody>
+          <a:bodyPr rtlCol="0" anchor="ctr"/>
+          <a:lstStyle/>
+          <a:p>
+            <a:pPr algn="ctr"/>
+          </a:p>
+        </p:txBody>
+      </p:sp>
+      <p:cxnSp>
+        <p:nvCxnSpPr>
+          <p:cNvPr id="25" name="Connector 24"/>
+          <p:cNvCxnSpPr/>
+          <p:nvPr/>
+        </p:nvCxnSpPr>
+        <p:spPr>
+          <a:xfrm>
+            <a:off x="6400800" y="640080"/>
+            <a:ext cx="0" cy="1325880"/>
+          </a:xfrm>
+          <a:prstGeom prst="line">
+            <a:avLst/>
+          </a:prstGeom>
+          <a:ln w="15875">
+            <a:solidFill>
+              <a:srgbClr val="000000"/>
+            </a:solidFill>
+          </a:ln>
+        </p:spPr>
+        <p:style>
+          <a:lnRef idx="2">
+            <a:schemeClr val="accent1"/>
+          </a:lnRef>
+          <a:fillRef idx="0">
+            <a:schemeClr val="accent1"/>
+          </a:fillRef>
+          <a:effectRef idx="1">
+            <a:schemeClr val="accent1"/>
+          </a:effectRef>
+          <a:fontRef idx="minor">
+            <a:schemeClr val="tx1"/>
+          </a:fontRef>
+        </p:style>
+      </p:cxnSp>
+      <p:cxnSp>
+        <p:nvCxnSpPr>
+          <p:cNvPr id="26" name="Connector 25"/>
+          <p:cNvCxnSpPr/>
+          <p:nvPr/>
+        </p:nvCxnSpPr>
+        <p:spPr>
+          <a:xfrm flipH="1">
+            <a:off x="5349240" y="1965960"/>
+            <a:ext cx="1051560" cy="0"/>
+          </a:xfrm>
+          <a:prstGeom prst="line">
+            <a:avLst/>
+          </a:prstGeom>
+          <a:ln w="15875">
+            <a:solidFill>
+              <a:srgbClr val="000000"/>
+            </a:solidFill>
+          </a:ln>
+        </p:spPr>
+        <p:style>
+          <a:lnRef idx="2">
+            <a:schemeClr val="accent1"/>
+          </a:lnRef>
+          <a:fillRef idx="0">
+            <a:schemeClr val="accent1"/>
+          </a:fillRef>
+          <a:effectRef idx="1">
+            <a:schemeClr val="accent1"/>
+          </a:effectRef>
+          <a:fontRef idx="minor">
+            <a:schemeClr val="tx1"/>
+          </a:fontRef>
+        </p:style>
+      </p:cxnSp>
+      <p:cxnSp>
+        <p:nvCxnSpPr>
+          <p:cNvPr id="27" name="Connector 26"/>
+          <p:cNvCxnSpPr/>
+          <p:nvPr/>
+        </p:nvCxnSpPr>
+        <p:spPr>
+          <a:xfrm>
+            <a:off x="5349240" y="1965960"/>
+            <a:ext cx="0" cy="960120"/>
+          </a:xfrm>
+          <a:prstGeom prst="line">
+            <a:avLst/>
+          </a:prstGeom>
+          <a:ln w="15875">
+            <a:solidFill>
+              <a:srgbClr val="000000"/>
+            </a:solidFill>
+            <a:tailEnd type="triangle" w="med" len="med"/>
+          </a:ln>
+        </p:spPr>
+        <p:style>
+          <a:lnRef idx="2">
+            <a:schemeClr val="accent1"/>
+          </a:lnRef>
+          <a:fillRef idx="0">
+            <a:schemeClr val="accent1"/>
+          </a:fillRef>
+          <a:effectRef idx="1">
+            <a:schemeClr val="accent1"/>
+          </a:effectRef>
+          <a:fontRef idx="minor">
+            <a:schemeClr val="tx1"/>
+          </a:fontRef>
+        </p:style>
+      </p:cxnSp>
+      <p:sp>
+        <p:nvSpPr>
+          <p:cNvPr id="28" name="Rectangle 27"/>
+          <p:cNvSpPr/>
+          <p:nvPr/>
+        </p:nvSpPr>
+        <p:spPr>
+          <a:xfrm>
+            <a:off x="5330952" y="2907792"/>
+            <a:ext cx="36576" cy="36576"/>
+          </a:xfrm>
+          <a:prstGeom prst="rect">
+            <a:avLst/>
+          </a:prstGeom>
+          <a:noFill/>
+          <a:ln>
+            <a:noFill/>
+          </a:ln>
+          <a:effectLst/>
+        </p:spPr>
+        <p:style>
+          <a:lnRef idx="1">
+            <a:schemeClr val="accent1"/>
+          </a:lnRef>
+          <a:fillRef idx="3">
+            <a:schemeClr val="accent1"/>
+          </a:fillRef>
+          <a:effectRef idx="2">
+            <a:schemeClr val="accent1"/>
+          </a:effectRef>
+          <a:fontRef idx="minor">
+            <a:schemeClr val="lt1"/>
+          </a:fontRef>
+        </p:style>
+        <p:txBody>
+          <a:bodyPr rtlCol="0" anchor="ctr"/>
+          <a:lstStyle/>
+          <a:p>
+            <a:pPr algn="ctr"/>
+          </a:p>
+        </p:txBody>
+      </p:sp>
+      <p:cxnSp>
+        <p:nvCxnSpPr>
+          <p:cNvPr id="29" name="Connector 28"/>
+          <p:cNvCxnSpPr/>
+          <p:nvPr/>
+        </p:nvCxnSpPr>
+        <p:spPr>
+          <a:xfrm>
+            <a:off x="8503920" y="640080"/>
+            <a:ext cx="0" cy="1691640"/>
+          </a:xfrm>
+          <a:prstGeom prst="line">
+            <a:avLst/>
+          </a:prstGeom>
+          <a:ln w="15875">
+            <a:solidFill>
+              <a:srgbClr val="000000"/>
+            </a:solidFill>
+          </a:ln>
+        </p:spPr>
+        <p:style>
+          <a:lnRef idx="2">
+            <a:schemeClr val="accent1"/>
+          </a:lnRef>
+          <a:fillRef idx="0">
+            <a:schemeClr val="accent1"/>
+          </a:fillRef>
+          <a:effectRef idx="1">
+            <a:schemeClr val="accent1"/>
+          </a:effectRef>
+          <a:fontRef idx="minor">
+            <a:schemeClr val="tx1"/>
+          </a:fontRef>
+        </p:style>
+      </p:cxnSp>
+      <p:cxnSp>
+        <p:nvCxnSpPr>
+          <p:cNvPr id="30" name="Connector 29"/>
+          <p:cNvCxnSpPr/>
+          <p:nvPr/>
+        </p:nvCxnSpPr>
+        <p:spPr>
+          <a:xfrm flipH="1">
+            <a:off x="5989320" y="2331720"/>
+            <a:ext cx="2514600" cy="0"/>
+          </a:xfrm>
+          <a:prstGeom prst="line">
+            <a:avLst/>
+          </a:prstGeom>
+          <a:ln w="15875">
+            <a:solidFill>
+              <a:srgbClr val="000000"/>
+            </a:solidFill>
+          </a:ln>
+        </p:spPr>
+        <p:style>
+          <a:lnRef idx="2">
+            <a:schemeClr val="accent1"/>
+          </a:lnRef>
+          <a:fillRef idx="0">
+            <a:schemeClr val="accent1"/>
+          </a:fillRef>
+          <a:effectRef idx="1">
+            <a:schemeClr val="accent1"/>
+          </a:effectRef>
+          <a:fontRef idx="minor">
+            <a:schemeClr val="tx1"/>
+          </a:fontRef>
+        </p:style>
+      </p:cxnSp>
+      <p:cxnSp>
+        <p:nvCxnSpPr>
+          <p:cNvPr id="31" name="Connector 30"/>
+          <p:cNvCxnSpPr/>
+          <p:nvPr/>
+        </p:nvCxnSpPr>
+        <p:spPr>
+          <a:xfrm>
+            <a:off x="5989320" y="2331720"/>
+            <a:ext cx="0" cy="594360"/>
+          </a:xfrm>
+          <a:prstGeom prst="line">
+            <a:avLst/>
+          </a:prstGeom>
+          <a:ln w="15875">
+            <a:solidFill>
+              <a:srgbClr val="000000"/>
+            </a:solidFill>
+            <a:tailEnd type="triangle" w="med" len="med"/>
+          </a:ln>
+        </p:spPr>
+        <p:style>
+          <a:lnRef idx="2">
+            <a:schemeClr val="accent1"/>
+          </a:lnRef>
+          <a:fillRef idx="0">
+            <a:schemeClr val="accent1"/>
+          </a:fillRef>
+          <a:effectRef idx="1">
+            <a:schemeClr val="accent1"/>
+          </a:effectRef>
+          <a:fontRef idx="minor">
+            <a:schemeClr val="tx1"/>
+          </a:fontRef>
+        </p:style>
+      </p:cxnSp>
+      <p:sp>
+        <p:nvSpPr>
+          <p:cNvPr id="32" name="Rectangle 31"/>
+          <p:cNvSpPr/>
+          <p:nvPr/>
+        </p:nvSpPr>
+        <p:spPr>
+          <a:xfrm>
+            <a:off x="5971032" y="2907792"/>
+            <a:ext cx="36576" cy="36576"/>
+          </a:xfrm>
+          <a:prstGeom prst="rect">
+            <a:avLst/>
+          </a:prstGeom>
+          <a:noFill/>
+          <a:ln>
+            <a:noFill/>
+          </a:ln>
+          <a:effectLst/>
+        </p:spPr>
+        <p:style>
+          <a:lnRef idx="1">
+            <a:schemeClr val="accent1"/>
+          </a:lnRef>
+          <a:fillRef idx="3">
+            <a:schemeClr val="accent1"/>
+          </a:fillRef>
+          <a:effectRef idx="2">
+            <a:schemeClr val="accent1"/>
+          </a:effectRef>
+          <a:fontRef idx="minor">
+            <a:schemeClr val="lt1"/>
+          </a:fontRef>
+        </p:style>
+        <p:txBody>
+          <a:bodyPr rtlCol="0" anchor="ctr"/>
+          <a:lstStyle/>
+          <a:p>
+            <a:pPr algn="ctr"/>
+          </a:p>
+        </p:txBody>
+      </p:sp>
+      <p:sp>
+        <p:nvSpPr>
+          <p:cNvPr id="33" name="TextBox 32"/>
           <p:cNvSpPr txBox="1"/>
           <p:nvPr/>
         </p:nvSpPr>
         <p:spPr>
           <a:xfrm>
-            <a:off x="502920" y="3703320"/>
-            <a:ext cx="3566160" cy="256032"/>
+            <a:off x="777240" y="329184"/>
+            <a:ext cx="2103120" cy="292608"/>
           </a:xfrm>
           <a:prstGeom prst="rect">
             <a:avLst/>
@@ -3408,14 +4279,119 @@
           <a:noFill/>
         </p:spPr>
         <p:txBody>
-          <a:bodyPr wrap="square" anchor="t" lIns="25400" rIns="25400" tIns="12700" bIns="12700">
+          <a:bodyPr wrap="square" anchor="t" lIns="6350" rIns="6350" tIns="6350" bIns="6350">
             <a:spAutoFit/>
           </a:bodyPr>
           <a:lstStyle/>
           <a:p>
-            <a:pPr algn="l"/>
-            <a:r>
-              <a:rPr sz="900" b="0">
+            <a:pPr algn="ctr"/>
+            <a:r>
+              <a:rPr sz="1000" b="0">
+                <a:solidFill>
+                  <a:srgbClr val="000000"/>
+                </a:solidFill>
+                <a:latin typeface="Arial"/>
+              </a:rPr>
+              <a:t>C1 Mission objectives and operational constraints</a:t>
+            </a:r>
+          </a:p>
+        </p:txBody>
+      </p:sp>
+      <p:sp>
+        <p:nvSpPr>
+          <p:cNvPr id="34" name="TextBox 33"/>
+          <p:cNvSpPr txBox="1"/>
+          <p:nvPr/>
+        </p:nvSpPr>
+        <p:spPr>
+          <a:xfrm>
+            <a:off x="2880360" y="329184"/>
+            <a:ext cx="2103120" cy="292608"/>
+          </a:xfrm>
+          <a:prstGeom prst="rect">
+            <a:avLst/>
+          </a:prstGeom>
+          <a:noFill/>
+        </p:spPr>
+        <p:txBody>
+          <a:bodyPr wrap="square" anchor="t" lIns="6350" rIns="6350" tIns="6350" bIns="6350">
+            <a:spAutoFit/>
+          </a:bodyPr>
+          <a:lstStyle/>
+          <a:p>
+            <a:pPr algn="ctr"/>
+            <a:r>
+              <a:rPr sz="1000" b="0">
+                <a:solidFill>
+                  <a:srgbClr val="000000"/>
+                </a:solidFill>
+                <a:latin typeface="Arial"/>
+              </a:rPr>
+              <a:t>C2 OPSEC / classification guidance</a:t>
+            </a:r>
+          </a:p>
+        </p:txBody>
+      </p:sp>
+      <p:sp>
+        <p:nvSpPr>
+          <p:cNvPr id="35" name="TextBox 34"/>
+          <p:cNvSpPr txBox="1"/>
+          <p:nvPr/>
+        </p:nvSpPr>
+        <p:spPr>
+          <a:xfrm>
+            <a:off x="5349240" y="329184"/>
+            <a:ext cx="2103120" cy="292608"/>
+          </a:xfrm>
+          <a:prstGeom prst="rect">
+            <a:avLst/>
+          </a:prstGeom>
+          <a:noFill/>
+        </p:spPr>
+        <p:txBody>
+          <a:bodyPr wrap="square" anchor="t" lIns="6350" rIns="6350" tIns="6350" bIns="6350">
+            <a:spAutoFit/>
+          </a:bodyPr>
+          <a:lstStyle/>
+          <a:p>
+            <a:pPr algn="ctr"/>
+            <a:r>
+              <a:rPr sz="1000" b="0">
+                <a:solidFill>
+                  <a:srgbClr val="000000"/>
+                </a:solidFill>
+                <a:latin typeface="Arial"/>
+              </a:rPr>
+              <a:t>C3 Network availability and DDS QoS policies</a:t>
+            </a:r>
+          </a:p>
+        </p:txBody>
+      </p:sp>
+      <p:sp>
+        <p:nvSpPr>
+          <p:cNvPr id="36" name="TextBox 35"/>
+          <p:cNvSpPr txBox="1"/>
+          <p:nvPr/>
+        </p:nvSpPr>
+        <p:spPr>
+          <a:xfrm>
+            <a:off x="7589520" y="329184"/>
+            <a:ext cx="2148840" cy="292608"/>
+          </a:xfrm>
+          <a:prstGeom prst="rect">
+            <a:avLst/>
+          </a:prstGeom>
+          <a:noFill/>
+        </p:spPr>
+        <p:txBody>
+          <a:bodyPr wrap="square" anchor="t" lIns="6350" rIns="6350" tIns="6350" bIns="6350">
+            <a:spAutoFit/>
+          </a:bodyPr>
+          <a:lstStyle/>
+          <a:p>
+            <a:pPr algn="ctr"/>
+            <a:r>
+              <a:rPr sz="1000" b="0">
                 <a:solidFill>
                   <a:srgbClr val="000000"/>
                 </a:solidFill>
@@ -3426,25 +4402,66 @@
           </a:p>
         </p:txBody>
       </p:sp>
+      <p:sp>
+        <p:nvSpPr>
+          <p:cNvPr id="37" name="Rectangle 36"/>
+          <p:cNvSpPr/>
+          <p:nvPr/>
+        </p:nvSpPr>
+        <p:spPr>
+          <a:xfrm>
+            <a:off x="6382512" y="3319272"/>
+            <a:ext cx="36576" cy="36576"/>
+          </a:xfrm>
+          <a:prstGeom prst="rect">
+            <a:avLst/>
+          </a:prstGeom>
+          <a:noFill/>
+          <a:ln>
+            <a:noFill/>
+          </a:ln>
+          <a:effectLst/>
+        </p:spPr>
+        <p:style>
+          <a:lnRef idx="1">
+            <a:schemeClr val="accent1"/>
+          </a:lnRef>
+          <a:fillRef idx="3">
+            <a:schemeClr val="accent1"/>
+          </a:fillRef>
+          <a:effectRef idx="2">
+            <a:schemeClr val="accent1"/>
+          </a:effectRef>
+          <a:fontRef idx="minor">
+            <a:schemeClr val="lt1"/>
+          </a:fontRef>
+        </p:style>
+        <p:txBody>
+          <a:bodyPr rtlCol="0" anchor="ctr"/>
+          <a:lstStyle/>
+          <a:p>
+            <a:pPr algn="ctr"/>
+          </a:p>
+        </p:txBody>
+      </p:sp>
       <p:cxnSp>
         <p:nvCxnSpPr>
-          <p:cNvPr id="11" name="Connector 10"/>
+          <p:cNvPr id="38" name="Connector 37"/>
           <p:cNvCxnSpPr/>
           <p:nvPr/>
         </p:nvCxnSpPr>
         <p:spPr>
           <a:xfrm>
-            <a:off x="4983480" y="868680"/>
-            <a:ext cx="0" cy="1737360"/>
+            <a:off x="6400800" y="3337560"/>
+            <a:ext cx="2011680" cy="0"/>
           </a:xfrm>
           <a:prstGeom prst="line">
             <a:avLst/>
           </a:prstGeom>
-          <a:ln w="19050">
+          <a:ln w="15875">
             <a:solidFill>
               <a:srgbClr val="000000"/>
             </a:solidFill>
-            <a:tailEnd type="triangle" w="med" len="med"/>
           </a:ln>
         </p:spPr>
         <p:style>
@@ -3462,60 +4479,24 @@
           </a:fontRef>
         </p:style>
       </p:cxnSp>
-      <p:sp>
-        <p:nvSpPr>
-          <p:cNvPr id="12" name="TextBox 11"/>
-          <p:cNvSpPr txBox="1"/>
-          <p:nvPr/>
-        </p:nvSpPr>
-        <p:spPr>
-          <a:xfrm>
-            <a:off x="4389120" y="91440"/>
-            <a:ext cx="1188720" cy="749808"/>
-          </a:xfrm>
-          <a:prstGeom prst="rect">
-            <a:avLst/>
-          </a:prstGeom>
-          <a:noFill/>
-        </p:spPr>
-        <p:txBody>
-          <a:bodyPr wrap="square" anchor="t" lIns="25400" rIns="25400" tIns="12700" bIns="12700">
-            <a:spAutoFit/>
-          </a:bodyPr>
-          <a:lstStyle/>
-          <a:p>
-            <a:pPr algn="ctr"/>
-            <a:r>
-              <a:rPr sz="800" b="0">
-                <a:solidFill>
-                  <a:srgbClr val="000000"/>
-                </a:solidFill>
-                <a:latin typeface="Arial"/>
-              </a:rPr>
-              <a:t>C1 Mission objectives and operational constraints</a:t>
-            </a:r>
-          </a:p>
-        </p:txBody>
-      </p:sp>
       <p:cxnSp>
         <p:nvCxnSpPr>
-          <p:cNvPr id="13" name="Connector 12"/>
+          <p:cNvPr id="39" name="Connector 38"/>
           <p:cNvCxnSpPr/>
           <p:nvPr/>
         </p:nvCxnSpPr>
         <p:spPr>
-          <a:xfrm>
-            <a:off x="6099048" y="868680"/>
-            <a:ext cx="0" cy="1737360"/>
+          <a:xfrm flipV="1">
+            <a:off x="8412480" y="3108960"/>
+            <a:ext cx="0" cy="228600"/>
           </a:xfrm>
           <a:prstGeom prst="line">
             <a:avLst/>
           </a:prstGeom>
-          <a:ln w="19050">
+          <a:ln w="15875">
             <a:solidFill>
               <a:srgbClr val="000000"/>
             </a:solidFill>
-            <a:tailEnd type="triangle" w="med" len="med"/>
           </a:ln>
         </p:spPr>
         <p:style>
@@ -3533,56 +4514,21 @@
           </a:fontRef>
         </p:style>
       </p:cxnSp>
-      <p:sp>
-        <p:nvSpPr>
-          <p:cNvPr id="14" name="TextBox 13"/>
-          <p:cNvSpPr txBox="1"/>
-          <p:nvPr/>
-        </p:nvSpPr>
-        <p:spPr>
-          <a:xfrm>
-            <a:off x="5504688" y="91440"/>
-            <a:ext cx="1188720" cy="749808"/>
-          </a:xfrm>
-          <a:prstGeom prst="rect">
-            <a:avLst/>
-          </a:prstGeom>
-          <a:noFill/>
-        </p:spPr>
-        <p:txBody>
-          <a:bodyPr wrap="square" anchor="t" lIns="25400" rIns="25400" tIns="12700" bIns="12700">
-            <a:spAutoFit/>
-          </a:bodyPr>
-          <a:lstStyle/>
-          <a:p>
-            <a:pPr algn="ctr"/>
-            <a:r>
-              <a:rPr sz="800" b="0">
-                <a:solidFill>
-                  <a:srgbClr val="000000"/>
-                </a:solidFill>
-                <a:latin typeface="Arial"/>
-              </a:rPr>
-              <a:t>C2 OPSEC / classification guidance</a:t>
-            </a:r>
-          </a:p>
-        </p:txBody>
-      </p:sp>
       <p:cxnSp>
         <p:nvCxnSpPr>
-          <p:cNvPr id="15" name="Connector 14"/>
+          <p:cNvPr id="40" name="Connector 39"/>
           <p:cNvCxnSpPr/>
           <p:nvPr/>
         </p:nvCxnSpPr>
         <p:spPr>
           <a:xfrm>
-            <a:off x="7223760" y="868680"/>
-            <a:ext cx="0" cy="1737360"/>
+            <a:off x="8412480" y="3108960"/>
+            <a:ext cx="1371600" cy="0"/>
           </a:xfrm>
           <a:prstGeom prst="line">
             <a:avLst/>
           </a:prstGeom>
-          <a:ln w="19050">
+          <a:ln w="15875">
             <a:solidFill>
               <a:srgbClr val="000000"/>
             </a:solidFill>
@@ -3606,58 +4552,64 @@
       </p:cxnSp>
       <p:sp>
         <p:nvSpPr>
-          <p:cNvPr id="16" name="TextBox 15"/>
-          <p:cNvSpPr txBox="1"/>
-          <p:nvPr/>
-        </p:nvSpPr>
-        <p:spPr>
-          <a:xfrm>
-            <a:off x="6629400" y="91440"/>
-            <a:ext cx="1188720" cy="749808"/>
+          <p:cNvPr id="41" name="Rectangle 40"/>
+          <p:cNvSpPr/>
+          <p:nvPr/>
+        </p:nvSpPr>
+        <p:spPr>
+          <a:xfrm>
+            <a:off x="6382512" y="3867912"/>
+            <a:ext cx="36576" cy="36576"/>
           </a:xfrm>
           <a:prstGeom prst="rect">
             <a:avLst/>
           </a:prstGeom>
           <a:noFill/>
-        </p:spPr>
-        <p:txBody>
-          <a:bodyPr wrap="square" anchor="t" lIns="25400" rIns="25400" tIns="12700" bIns="12700">
-            <a:spAutoFit/>
-          </a:bodyPr>
+          <a:ln>
+            <a:noFill/>
+          </a:ln>
+          <a:effectLst/>
+        </p:spPr>
+        <p:style>
+          <a:lnRef idx="1">
+            <a:schemeClr val="accent1"/>
+          </a:lnRef>
+          <a:fillRef idx="3">
+            <a:schemeClr val="accent1"/>
+          </a:fillRef>
+          <a:effectRef idx="2">
+            <a:schemeClr val="accent1"/>
+          </a:effectRef>
+          <a:fontRef idx="minor">
+            <a:schemeClr val="lt1"/>
+          </a:fontRef>
+        </p:style>
+        <p:txBody>
+          <a:bodyPr rtlCol="0" anchor="ctr"/>
           <a:lstStyle/>
           <a:p>
             <a:pPr algn="ctr"/>
-            <a:r>
-              <a:rPr sz="800" b="0">
-                <a:solidFill>
-                  <a:srgbClr val="000000"/>
-                </a:solidFill>
-                <a:latin typeface="Arial"/>
-              </a:rPr>
-              <a:t>C3 Network availability and DDS QoS policies</a:t>
-            </a:r>
           </a:p>
         </p:txBody>
       </p:sp>
       <p:cxnSp>
         <p:nvCxnSpPr>
-          <p:cNvPr id="17" name="Connector 16"/>
+          <p:cNvPr id="42" name="Connector 41"/>
           <p:cNvCxnSpPr/>
           <p:nvPr/>
         </p:nvCxnSpPr>
         <p:spPr>
           <a:xfrm>
-            <a:off x="7744968" y="2880360"/>
-            <a:ext cx="4005072" cy="0"/>
+            <a:off x="6400800" y="3886200"/>
+            <a:ext cx="2286000" cy="0"/>
           </a:xfrm>
           <a:prstGeom prst="line">
             <a:avLst/>
           </a:prstGeom>
-          <a:ln w="19050">
+          <a:ln w="15875">
             <a:solidFill>
               <a:srgbClr val="000000"/>
             </a:solidFill>
-            <a:tailEnd type="triangle" w="med" len="med"/>
           </a:ln>
         </p:spPr>
         <p:style>
@@ -3675,16 +4627,235 @@
           </a:fontRef>
         </p:style>
       </p:cxnSp>
-      <p:sp>
-        <p:nvSpPr>
-          <p:cNvPr id="18" name="TextBox 17"/>
+      <p:cxnSp>
+        <p:nvCxnSpPr>
+          <p:cNvPr id="43" name="Connector 42"/>
+          <p:cNvCxnSpPr/>
+          <p:nvPr/>
+        </p:nvCxnSpPr>
+        <p:spPr>
+          <a:xfrm>
+            <a:off x="8686800" y="3886200"/>
+            <a:ext cx="0" cy="228600"/>
+          </a:xfrm>
+          <a:prstGeom prst="line">
+            <a:avLst/>
+          </a:prstGeom>
+          <a:ln w="15875">
+            <a:solidFill>
+              <a:srgbClr val="000000"/>
+            </a:solidFill>
+          </a:ln>
+        </p:spPr>
+        <p:style>
+          <a:lnRef idx="2">
+            <a:schemeClr val="accent1"/>
+          </a:lnRef>
+          <a:fillRef idx="0">
+            <a:schemeClr val="accent1"/>
+          </a:fillRef>
+          <a:effectRef idx="1">
+            <a:schemeClr val="accent1"/>
+          </a:effectRef>
+          <a:fontRef idx="minor">
+            <a:schemeClr val="tx1"/>
+          </a:fontRef>
+        </p:style>
+      </p:cxnSp>
+      <p:cxnSp>
+        <p:nvCxnSpPr>
+          <p:cNvPr id="44" name="Connector 43"/>
+          <p:cNvCxnSpPr/>
+          <p:nvPr/>
+        </p:nvCxnSpPr>
+        <p:spPr>
+          <a:xfrm>
+            <a:off x="8686800" y="4114800"/>
+            <a:ext cx="1097280" cy="0"/>
+          </a:xfrm>
+          <a:prstGeom prst="line">
+            <a:avLst/>
+          </a:prstGeom>
+          <a:ln w="15875">
+            <a:solidFill>
+              <a:srgbClr val="000000"/>
+            </a:solidFill>
+            <a:tailEnd type="triangle" w="med" len="med"/>
+          </a:ln>
+        </p:spPr>
+        <p:style>
+          <a:lnRef idx="2">
+            <a:schemeClr val="accent1"/>
+          </a:lnRef>
+          <a:fillRef idx="0">
+            <a:schemeClr val="accent1"/>
+          </a:fillRef>
+          <a:effectRef idx="1">
+            <a:schemeClr val="accent1"/>
+          </a:effectRef>
+          <a:fontRef idx="minor">
+            <a:schemeClr val="tx1"/>
+          </a:fontRef>
+        </p:style>
+      </p:cxnSp>
+      <p:sp>
+        <p:nvSpPr>
+          <p:cNvPr id="45" name="Rectangle 44"/>
+          <p:cNvSpPr/>
+          <p:nvPr/>
+        </p:nvSpPr>
+        <p:spPr>
+          <a:xfrm>
+            <a:off x="6382512" y="4416552"/>
+            <a:ext cx="36576" cy="36576"/>
+          </a:xfrm>
+          <a:prstGeom prst="rect">
+            <a:avLst/>
+          </a:prstGeom>
+          <a:noFill/>
+          <a:ln>
+            <a:noFill/>
+          </a:ln>
+          <a:effectLst/>
+        </p:spPr>
+        <p:style>
+          <a:lnRef idx="1">
+            <a:schemeClr val="accent1"/>
+          </a:lnRef>
+          <a:fillRef idx="3">
+            <a:schemeClr val="accent1"/>
+          </a:fillRef>
+          <a:effectRef idx="2">
+            <a:schemeClr val="accent1"/>
+          </a:effectRef>
+          <a:fontRef idx="minor">
+            <a:schemeClr val="lt1"/>
+          </a:fontRef>
+        </p:style>
+        <p:txBody>
+          <a:bodyPr rtlCol="0" anchor="ctr"/>
+          <a:lstStyle/>
+          <a:p>
+            <a:pPr algn="ctr"/>
+          </a:p>
+        </p:txBody>
+      </p:sp>
+      <p:cxnSp>
+        <p:nvCxnSpPr>
+          <p:cNvPr id="46" name="Connector 45"/>
+          <p:cNvCxnSpPr/>
+          <p:nvPr/>
+        </p:nvCxnSpPr>
+        <p:spPr>
+          <a:xfrm>
+            <a:off x="6400800" y="4434840"/>
+            <a:ext cx="2011680" cy="0"/>
+          </a:xfrm>
+          <a:prstGeom prst="line">
+            <a:avLst/>
+          </a:prstGeom>
+          <a:ln w="15875">
+            <a:solidFill>
+              <a:srgbClr val="000000"/>
+            </a:solidFill>
+          </a:ln>
+        </p:spPr>
+        <p:style>
+          <a:lnRef idx="2">
+            <a:schemeClr val="accent1"/>
+          </a:lnRef>
+          <a:fillRef idx="0">
+            <a:schemeClr val="accent1"/>
+          </a:fillRef>
+          <a:effectRef idx="1">
+            <a:schemeClr val="accent1"/>
+          </a:effectRef>
+          <a:fontRef idx="minor">
+            <a:schemeClr val="tx1"/>
+          </a:fontRef>
+        </p:style>
+      </p:cxnSp>
+      <p:cxnSp>
+        <p:nvCxnSpPr>
+          <p:cNvPr id="47" name="Connector 46"/>
+          <p:cNvCxnSpPr/>
+          <p:nvPr/>
+        </p:nvCxnSpPr>
+        <p:spPr>
+          <a:xfrm>
+            <a:off x="8412480" y="4434840"/>
+            <a:ext cx="0" cy="228600"/>
+          </a:xfrm>
+          <a:prstGeom prst="line">
+            <a:avLst/>
+          </a:prstGeom>
+          <a:ln w="15875">
+            <a:solidFill>
+              <a:srgbClr val="000000"/>
+            </a:solidFill>
+          </a:ln>
+        </p:spPr>
+        <p:style>
+          <a:lnRef idx="2">
+            <a:schemeClr val="accent1"/>
+          </a:lnRef>
+          <a:fillRef idx="0">
+            <a:schemeClr val="accent1"/>
+          </a:fillRef>
+          <a:effectRef idx="1">
+            <a:schemeClr val="accent1"/>
+          </a:effectRef>
+          <a:fontRef idx="minor">
+            <a:schemeClr val="tx1"/>
+          </a:fontRef>
+        </p:style>
+      </p:cxnSp>
+      <p:cxnSp>
+        <p:nvCxnSpPr>
+          <p:cNvPr id="48" name="Connector 47"/>
+          <p:cNvCxnSpPr/>
+          <p:nvPr/>
+        </p:nvCxnSpPr>
+        <p:spPr>
+          <a:xfrm>
+            <a:off x="8412480" y="4663440"/>
+            <a:ext cx="1371600" cy="0"/>
+          </a:xfrm>
+          <a:prstGeom prst="line">
+            <a:avLst/>
+          </a:prstGeom>
+          <a:ln w="15875">
+            <a:solidFill>
+              <a:srgbClr val="000000"/>
+            </a:solidFill>
+            <a:tailEnd type="triangle" w="med" len="med"/>
+          </a:ln>
+        </p:spPr>
+        <p:style>
+          <a:lnRef idx="2">
+            <a:schemeClr val="accent1"/>
+          </a:lnRef>
+          <a:fillRef idx="0">
+            <a:schemeClr val="accent1"/>
+          </a:fillRef>
+          <a:effectRef idx="1">
+            <a:schemeClr val="accent1"/>
+          </a:effectRef>
+          <a:fontRef idx="minor">
+            <a:schemeClr val="tx1"/>
+          </a:fontRef>
+        </p:style>
+      </p:cxnSp>
+      <p:sp>
+        <p:nvSpPr>
+          <p:cNvPr id="49" name="TextBox 48"/>
           <p:cNvSpPr txBox="1"/>
           <p:nvPr/>
         </p:nvSpPr>
         <p:spPr>
           <a:xfrm>
-            <a:off x="7863840" y="2606040"/>
-            <a:ext cx="3749039" cy="256032"/>
+            <a:off x="6537960" y="2999232"/>
+            <a:ext cx="3017520" cy="292608"/>
           </a:xfrm>
           <a:prstGeom prst="rect">
             <a:avLst/>
@@ -3692,14 +4863,14 @@
           <a:noFill/>
         </p:spPr>
         <p:txBody>
-          <a:bodyPr wrap="square" anchor="t" lIns="25400" rIns="25400" tIns="12700" bIns="12700">
+          <a:bodyPr wrap="square" anchor="t" lIns="6350" rIns="6350" tIns="6350" bIns="6350">
             <a:spAutoFit/>
           </a:bodyPr>
           <a:lstStyle/>
           <a:p>
             <a:pPr algn="l"/>
             <a:r>
-              <a:rPr sz="900" b="0">
+              <a:rPr sz="1000" b="0">
                 <a:solidFill>
                   <a:srgbClr val="000000"/>
                 </a:solidFill>
@@ -3710,25 +4881,94 @@
           </a:p>
         </p:txBody>
       </p:sp>
+      <p:sp>
+        <p:nvSpPr>
+          <p:cNvPr id="50" name="TextBox 49"/>
+          <p:cNvSpPr txBox="1"/>
+          <p:nvPr/>
+        </p:nvSpPr>
+        <p:spPr>
+          <a:xfrm>
+            <a:off x="6537960" y="3547872"/>
+            <a:ext cx="3017520" cy="292608"/>
+          </a:xfrm>
+          <a:prstGeom prst="rect">
+            <a:avLst/>
+          </a:prstGeom>
+          <a:noFill/>
+        </p:spPr>
+        <p:txBody>
+          <a:bodyPr wrap="square" anchor="t" lIns="6350" rIns="6350" tIns="6350" bIns="6350">
+            <a:spAutoFit/>
+          </a:bodyPr>
+          <a:lstStyle/>
+          <a:p>
+            <a:pPr algn="l"/>
+            <a:r>
+              <a:rPr sz="1000" b="0">
+                <a:solidFill>
+                  <a:srgbClr val="000000"/>
+                </a:solidFill>
+                <a:latin typeface="Arial"/>
+              </a:rPr>
+              <a:t>O2 Mission-Tailored COWP Excerpts</a:t>
+            </a:r>
+          </a:p>
+        </p:txBody>
+      </p:sp>
+      <p:sp>
+        <p:nvSpPr>
+          <p:cNvPr id="51" name="TextBox 50"/>
+          <p:cNvSpPr txBox="1"/>
+          <p:nvPr/>
+        </p:nvSpPr>
+        <p:spPr>
+          <a:xfrm>
+            <a:off x="6537960" y="4096512"/>
+            <a:ext cx="3017520" cy="292608"/>
+          </a:xfrm>
+          <a:prstGeom prst="rect">
+            <a:avLst/>
+          </a:prstGeom>
+          <a:noFill/>
+        </p:spPr>
+        <p:txBody>
+          <a:bodyPr wrap="square" anchor="t" lIns="6350" rIns="6350" tIns="6350" bIns="6350">
+            <a:spAutoFit/>
+          </a:bodyPr>
+          <a:lstStyle/>
+          <a:p>
+            <a:pPr algn="l"/>
+            <a:r>
+              <a:rPr sz="1000" b="0">
+                <a:solidFill>
+                  <a:srgbClr val="000000"/>
+                </a:solidFill>
+                <a:latin typeface="Arial"/>
+              </a:rPr>
+              <a:t>O3 Weather State Change Notifications</a:t>
+            </a:r>
+          </a:p>
+        </p:txBody>
+      </p:sp>
       <p:cxnSp>
         <p:nvCxnSpPr>
-          <p:cNvPr id="19" name="Connector 18"/>
+          <p:cNvPr id="52" name="Connector 51"/>
           <p:cNvCxnSpPr/>
           <p:nvPr/>
         </p:nvCxnSpPr>
         <p:spPr>
-          <a:xfrm>
-            <a:off x="7744968" y="3429000"/>
-            <a:ext cx="4005072" cy="0"/>
+          <a:xfrm flipV="1">
+            <a:off x="2743200" y="6217920"/>
+            <a:ext cx="0" cy="1097280"/>
           </a:xfrm>
           <a:prstGeom prst="line">
             <a:avLst/>
           </a:prstGeom>
-          <a:ln w="19050">
+          <a:ln w="15875">
             <a:solidFill>
               <a:srgbClr val="000000"/>
             </a:solidFill>
-            <a:tailEnd type="triangle" w="med" len="med"/>
           </a:ln>
         </p:spPr>
         <p:style>
@@ -3746,60 +4986,24 @@
           </a:fontRef>
         </p:style>
       </p:cxnSp>
-      <p:sp>
-        <p:nvSpPr>
-          <p:cNvPr id="20" name="TextBox 19"/>
-          <p:cNvSpPr txBox="1"/>
-          <p:nvPr/>
-        </p:nvSpPr>
-        <p:spPr>
-          <a:xfrm>
-            <a:off x="7863840" y="3154680"/>
-            <a:ext cx="3749039" cy="256032"/>
-          </a:xfrm>
-          <a:prstGeom prst="rect">
-            <a:avLst/>
-          </a:prstGeom>
-          <a:noFill/>
-        </p:spPr>
-        <p:txBody>
-          <a:bodyPr wrap="square" anchor="t" lIns="25400" rIns="25400" tIns="12700" bIns="12700">
-            <a:spAutoFit/>
-          </a:bodyPr>
-          <a:lstStyle/>
-          <a:p>
-            <a:pPr algn="l"/>
-            <a:r>
-              <a:rPr sz="900" b="0">
-                <a:solidFill>
-                  <a:srgbClr val="000000"/>
-                </a:solidFill>
-                <a:latin typeface="Arial"/>
-              </a:rPr>
-              <a:t>O2 Mission-Tailored COWP Excerpts</a:t>
-            </a:r>
-          </a:p>
-        </p:txBody>
-      </p:sp>
       <p:cxnSp>
         <p:nvCxnSpPr>
-          <p:cNvPr id="21" name="Connector 20"/>
+          <p:cNvPr id="53" name="Connector 52"/>
           <p:cNvCxnSpPr/>
           <p:nvPr/>
         </p:nvCxnSpPr>
         <p:spPr>
           <a:xfrm>
-            <a:off x="7744968" y="3977639"/>
-            <a:ext cx="4005072" cy="0"/>
+            <a:off x="2743200" y="6217920"/>
+            <a:ext cx="1463040" cy="0"/>
           </a:xfrm>
           <a:prstGeom prst="line">
             <a:avLst/>
           </a:prstGeom>
-          <a:ln w="19050">
+          <a:ln w="15875">
             <a:solidFill>
               <a:srgbClr val="000000"/>
             </a:solidFill>
-            <a:tailEnd type="triangle" w="med" len="med"/>
           </a:ln>
         </p:spPr>
         <p:style>
@@ -3817,56 +5021,21 @@
           </a:fontRef>
         </p:style>
       </p:cxnSp>
-      <p:sp>
-        <p:nvSpPr>
-          <p:cNvPr id="22" name="TextBox 21"/>
-          <p:cNvSpPr txBox="1"/>
-          <p:nvPr/>
-        </p:nvSpPr>
-        <p:spPr>
-          <a:xfrm>
-            <a:off x="7863840" y="3703320"/>
-            <a:ext cx="3749039" cy="256032"/>
-          </a:xfrm>
-          <a:prstGeom prst="rect">
-            <a:avLst/>
-          </a:prstGeom>
-          <a:noFill/>
-        </p:spPr>
-        <p:txBody>
-          <a:bodyPr wrap="square" anchor="t" lIns="25400" rIns="25400" tIns="12700" bIns="12700">
-            <a:spAutoFit/>
-          </a:bodyPr>
-          <a:lstStyle/>
-          <a:p>
-            <a:pPr algn="l"/>
-            <a:r>
-              <a:rPr sz="900" b="0">
-                <a:solidFill>
-                  <a:srgbClr val="000000"/>
-                </a:solidFill>
-                <a:latin typeface="Arial"/>
-              </a:rPr>
-              <a:t>O3 Weather State Change Notifications</a:t>
-            </a:r>
-          </a:p>
-        </p:txBody>
-      </p:sp>
       <p:cxnSp>
         <p:nvCxnSpPr>
-          <p:cNvPr id="23" name="Connector 22"/>
+          <p:cNvPr id="54" name="Connector 53"/>
           <p:cNvCxnSpPr/>
           <p:nvPr/>
         </p:nvCxnSpPr>
         <p:spPr>
           <a:xfrm flipV="1">
-            <a:off x="4983480" y="4251960"/>
-            <a:ext cx="0" cy="1737360"/>
+            <a:off x="4206240" y="4846320"/>
+            <a:ext cx="0" cy="1371600"/>
           </a:xfrm>
           <a:prstGeom prst="line">
             <a:avLst/>
           </a:prstGeom>
-          <a:ln w="19050">
+          <a:ln w="15875">
             <a:solidFill>
               <a:srgbClr val="000000"/>
             </a:solidFill>
@@ -3890,14 +5059,352 @@
       </p:cxnSp>
       <p:sp>
         <p:nvSpPr>
-          <p:cNvPr id="24" name="TextBox 23"/>
+          <p:cNvPr id="55" name="Rectangle 54"/>
+          <p:cNvSpPr/>
+          <p:nvPr/>
+        </p:nvSpPr>
+        <p:spPr>
+          <a:xfrm>
+            <a:off x="4187952" y="4828032"/>
+            <a:ext cx="36576" cy="36576"/>
+          </a:xfrm>
+          <a:prstGeom prst="rect">
+            <a:avLst/>
+          </a:prstGeom>
+          <a:noFill/>
+          <a:ln>
+            <a:noFill/>
+          </a:ln>
+          <a:effectLst/>
+        </p:spPr>
+        <p:style>
+          <a:lnRef idx="1">
+            <a:schemeClr val="accent1"/>
+          </a:lnRef>
+          <a:fillRef idx="3">
+            <a:schemeClr val="accent1"/>
+          </a:fillRef>
+          <a:effectRef idx="2">
+            <a:schemeClr val="accent1"/>
+          </a:effectRef>
+          <a:fontRef idx="minor">
+            <a:schemeClr val="lt1"/>
+          </a:fontRef>
+        </p:style>
+        <p:txBody>
+          <a:bodyPr rtlCol="0" anchor="ctr"/>
+          <a:lstStyle/>
+          <a:p>
+            <a:pPr algn="ctr"/>
+          </a:p>
+        </p:txBody>
+      </p:sp>
+      <p:cxnSp>
+        <p:nvCxnSpPr>
+          <p:cNvPr id="56" name="Connector 55"/>
+          <p:cNvCxnSpPr/>
+          <p:nvPr/>
+        </p:nvCxnSpPr>
+        <p:spPr>
+          <a:xfrm flipV="1">
+            <a:off x="4754880" y="6400800"/>
+            <a:ext cx="0" cy="914400"/>
+          </a:xfrm>
+          <a:prstGeom prst="line">
+            <a:avLst/>
+          </a:prstGeom>
+          <a:ln w="15875">
+            <a:solidFill>
+              <a:srgbClr val="000000"/>
+            </a:solidFill>
+          </a:ln>
+        </p:spPr>
+        <p:style>
+          <a:lnRef idx="2">
+            <a:schemeClr val="accent1"/>
+          </a:lnRef>
+          <a:fillRef idx="0">
+            <a:schemeClr val="accent1"/>
+          </a:fillRef>
+          <a:effectRef idx="1">
+            <a:schemeClr val="accent1"/>
+          </a:effectRef>
+          <a:fontRef idx="minor">
+            <a:schemeClr val="tx1"/>
+          </a:fontRef>
+        </p:style>
+      </p:cxnSp>
+      <p:cxnSp>
+        <p:nvCxnSpPr>
+          <p:cNvPr id="57" name="Connector 56"/>
+          <p:cNvCxnSpPr/>
+          <p:nvPr/>
+        </p:nvCxnSpPr>
+        <p:spPr>
+          <a:xfrm>
+            <a:off x="4754880" y="6400800"/>
+            <a:ext cx="274320" cy="0"/>
+          </a:xfrm>
+          <a:prstGeom prst="line">
+            <a:avLst/>
+          </a:prstGeom>
+          <a:ln w="15875">
+            <a:solidFill>
+              <a:srgbClr val="000000"/>
+            </a:solidFill>
+          </a:ln>
+        </p:spPr>
+        <p:style>
+          <a:lnRef idx="2">
+            <a:schemeClr val="accent1"/>
+          </a:lnRef>
+          <a:fillRef idx="0">
+            <a:schemeClr val="accent1"/>
+          </a:fillRef>
+          <a:effectRef idx="1">
+            <a:schemeClr val="accent1"/>
+          </a:effectRef>
+          <a:fontRef idx="minor">
+            <a:schemeClr val="tx1"/>
+          </a:fontRef>
+        </p:style>
+      </p:cxnSp>
+      <p:cxnSp>
+        <p:nvCxnSpPr>
+          <p:cNvPr id="58" name="Connector 57"/>
+          <p:cNvCxnSpPr/>
+          <p:nvPr/>
+        </p:nvCxnSpPr>
+        <p:spPr>
+          <a:xfrm flipV="1">
+            <a:off x="5029200" y="4846320"/>
+            <a:ext cx="0" cy="1554480"/>
+          </a:xfrm>
+          <a:prstGeom prst="line">
+            <a:avLst/>
+          </a:prstGeom>
+          <a:ln w="15875">
+            <a:solidFill>
+              <a:srgbClr val="000000"/>
+            </a:solidFill>
+            <a:tailEnd type="triangle" w="med" len="med"/>
+          </a:ln>
+        </p:spPr>
+        <p:style>
+          <a:lnRef idx="2">
+            <a:schemeClr val="accent1"/>
+          </a:lnRef>
+          <a:fillRef idx="0">
+            <a:schemeClr val="accent1"/>
+          </a:fillRef>
+          <a:effectRef idx="1">
+            <a:schemeClr val="accent1"/>
+          </a:effectRef>
+          <a:fontRef idx="minor">
+            <a:schemeClr val="tx1"/>
+          </a:fontRef>
+        </p:style>
+      </p:cxnSp>
+      <p:sp>
+        <p:nvSpPr>
+          <p:cNvPr id="59" name="Rectangle 58"/>
+          <p:cNvSpPr/>
+          <p:nvPr/>
+        </p:nvSpPr>
+        <p:spPr>
+          <a:xfrm>
+            <a:off x="5010912" y="4828032"/>
+            <a:ext cx="36576" cy="36576"/>
+          </a:xfrm>
+          <a:prstGeom prst="rect">
+            <a:avLst/>
+          </a:prstGeom>
+          <a:noFill/>
+          <a:ln>
+            <a:noFill/>
+          </a:ln>
+          <a:effectLst/>
+        </p:spPr>
+        <p:style>
+          <a:lnRef idx="1">
+            <a:schemeClr val="accent1"/>
+          </a:lnRef>
+          <a:fillRef idx="3">
+            <a:schemeClr val="accent1"/>
+          </a:fillRef>
+          <a:effectRef idx="2">
+            <a:schemeClr val="accent1"/>
+          </a:effectRef>
+          <a:fontRef idx="minor">
+            <a:schemeClr val="lt1"/>
+          </a:fontRef>
+        </p:style>
+        <p:txBody>
+          <a:bodyPr rtlCol="0" anchor="ctr"/>
+          <a:lstStyle/>
+          <a:p>
+            <a:pPr algn="ctr"/>
+          </a:p>
+        </p:txBody>
+      </p:sp>
+      <p:cxnSp>
+        <p:nvCxnSpPr>
+          <p:cNvPr id="60" name="Connector 59"/>
+          <p:cNvCxnSpPr/>
+          <p:nvPr/>
+        </p:nvCxnSpPr>
+        <p:spPr>
+          <a:xfrm flipV="1">
+            <a:off x="7315200" y="6583680"/>
+            <a:ext cx="0" cy="731520"/>
+          </a:xfrm>
+          <a:prstGeom prst="line">
+            <a:avLst/>
+          </a:prstGeom>
+          <a:ln w="15875">
+            <a:solidFill>
+              <a:srgbClr val="000000"/>
+            </a:solidFill>
+          </a:ln>
+        </p:spPr>
+        <p:style>
+          <a:lnRef idx="2">
+            <a:schemeClr val="accent1"/>
+          </a:lnRef>
+          <a:fillRef idx="0">
+            <a:schemeClr val="accent1"/>
+          </a:fillRef>
+          <a:effectRef idx="1">
+            <a:schemeClr val="accent1"/>
+          </a:effectRef>
+          <a:fontRef idx="minor">
+            <a:schemeClr val="tx1"/>
+          </a:fontRef>
+        </p:style>
+      </p:cxnSp>
+      <p:cxnSp>
+        <p:nvCxnSpPr>
+          <p:cNvPr id="61" name="Connector 60"/>
+          <p:cNvCxnSpPr/>
+          <p:nvPr/>
+        </p:nvCxnSpPr>
+        <p:spPr>
+          <a:xfrm flipH="1">
+            <a:off x="5852160" y="6583680"/>
+            <a:ext cx="1463040" cy="0"/>
+          </a:xfrm>
+          <a:prstGeom prst="line">
+            <a:avLst/>
+          </a:prstGeom>
+          <a:ln w="15875">
+            <a:solidFill>
+              <a:srgbClr val="000000"/>
+            </a:solidFill>
+          </a:ln>
+        </p:spPr>
+        <p:style>
+          <a:lnRef idx="2">
+            <a:schemeClr val="accent1"/>
+          </a:lnRef>
+          <a:fillRef idx="0">
+            <a:schemeClr val="accent1"/>
+          </a:fillRef>
+          <a:effectRef idx="1">
+            <a:schemeClr val="accent1"/>
+          </a:effectRef>
+          <a:fontRef idx="minor">
+            <a:schemeClr val="tx1"/>
+          </a:fontRef>
+        </p:style>
+      </p:cxnSp>
+      <p:cxnSp>
+        <p:nvCxnSpPr>
+          <p:cNvPr id="62" name="Connector 61"/>
+          <p:cNvCxnSpPr/>
+          <p:nvPr/>
+        </p:nvCxnSpPr>
+        <p:spPr>
+          <a:xfrm flipV="1">
+            <a:off x="5852160" y="4846320"/>
+            <a:ext cx="0" cy="1737360"/>
+          </a:xfrm>
+          <a:prstGeom prst="line">
+            <a:avLst/>
+          </a:prstGeom>
+          <a:ln w="15875">
+            <a:solidFill>
+              <a:srgbClr val="000000"/>
+            </a:solidFill>
+            <a:tailEnd type="triangle" w="med" len="med"/>
+          </a:ln>
+        </p:spPr>
+        <p:style>
+          <a:lnRef idx="2">
+            <a:schemeClr val="accent1"/>
+          </a:lnRef>
+          <a:fillRef idx="0">
+            <a:schemeClr val="accent1"/>
+          </a:fillRef>
+          <a:effectRef idx="1">
+            <a:schemeClr val="accent1"/>
+          </a:effectRef>
+          <a:fontRef idx="minor">
+            <a:schemeClr val="tx1"/>
+          </a:fontRef>
+        </p:style>
+      </p:cxnSp>
+      <p:sp>
+        <p:nvSpPr>
+          <p:cNvPr id="63" name="Rectangle 62"/>
+          <p:cNvSpPr/>
+          <p:nvPr/>
+        </p:nvSpPr>
+        <p:spPr>
+          <a:xfrm>
+            <a:off x="5833872" y="4828032"/>
+            <a:ext cx="36576" cy="36576"/>
+          </a:xfrm>
+          <a:prstGeom prst="rect">
+            <a:avLst/>
+          </a:prstGeom>
+          <a:noFill/>
+          <a:ln>
+            <a:noFill/>
+          </a:ln>
+          <a:effectLst/>
+        </p:spPr>
+        <p:style>
+          <a:lnRef idx="1">
+            <a:schemeClr val="accent1"/>
+          </a:lnRef>
+          <a:fillRef idx="3">
+            <a:schemeClr val="accent1"/>
+          </a:fillRef>
+          <a:effectRef idx="2">
+            <a:schemeClr val="accent1"/>
+          </a:effectRef>
+          <a:fontRef idx="minor">
+            <a:schemeClr val="lt1"/>
+          </a:fontRef>
+        </p:style>
+        <p:txBody>
+          <a:bodyPr rtlCol="0" anchor="ctr"/>
+          <a:lstStyle/>
+          <a:p>
+            <a:pPr algn="ctr"/>
+          </a:p>
+        </p:txBody>
+      </p:sp>
+      <p:sp>
+        <p:nvSpPr>
+          <p:cNvPr id="64" name="TextBox 63"/>
           <p:cNvSpPr txBox="1"/>
           <p:nvPr/>
         </p:nvSpPr>
         <p:spPr>
           <a:xfrm>
-            <a:off x="4389120" y="6053328"/>
-            <a:ext cx="1188720" cy="749808"/>
+            <a:off x="1600200" y="7370064"/>
+            <a:ext cx="2286000" cy="292608"/>
           </a:xfrm>
           <a:prstGeom prst="rect">
             <a:avLst/>
@@ -3905,14 +5412,14 @@
           <a:noFill/>
         </p:spPr>
         <p:txBody>
-          <a:bodyPr wrap="square" anchor="t" lIns="25400" rIns="25400" tIns="12700" bIns="12700">
+          <a:bodyPr wrap="square" anchor="t" lIns="6350" rIns="6350" tIns="6350" bIns="6350">
             <a:spAutoFit/>
           </a:bodyPr>
           <a:lstStyle/>
           <a:p>
             <a:pPr algn="ctr"/>
             <a:r>
-              <a:rPr sz="800" b="0">
+              <a:rPr sz="1000" b="0">
                 <a:solidFill>
                   <a:srgbClr val="000000"/>
                 </a:solidFill>
@@ -3923,52 +5430,16 @@
           </a:p>
         </p:txBody>
       </p:sp>
-      <p:cxnSp>
-        <p:nvCxnSpPr>
-          <p:cNvPr id="25" name="Connector 24"/>
-          <p:cNvCxnSpPr/>
-          <p:nvPr/>
-        </p:nvCxnSpPr>
-        <p:spPr>
-          <a:xfrm flipV="1">
-            <a:off x="6099048" y="4251960"/>
-            <a:ext cx="0" cy="1737360"/>
-          </a:xfrm>
-          <a:prstGeom prst="line">
-            <a:avLst/>
-          </a:prstGeom>
-          <a:ln w="19050">
-            <a:solidFill>
-              <a:srgbClr val="000000"/>
-            </a:solidFill>
-            <a:tailEnd type="triangle" w="med" len="med"/>
-          </a:ln>
-        </p:spPr>
-        <p:style>
-          <a:lnRef idx="2">
-            <a:schemeClr val="accent1"/>
-          </a:lnRef>
-          <a:fillRef idx="0">
-            <a:schemeClr val="accent1"/>
-          </a:fillRef>
-          <a:effectRef idx="1">
-            <a:schemeClr val="accent1"/>
-          </a:effectRef>
-          <a:fontRef idx="minor">
-            <a:schemeClr val="tx1"/>
-          </a:fontRef>
-        </p:style>
-      </p:cxnSp>
-      <p:sp>
-        <p:nvSpPr>
-          <p:cNvPr id="26" name="TextBox 25"/>
+      <p:sp>
+        <p:nvSpPr>
+          <p:cNvPr id="65" name="TextBox 64"/>
           <p:cNvSpPr txBox="1"/>
           <p:nvPr/>
         </p:nvSpPr>
         <p:spPr>
           <a:xfrm>
-            <a:off x="5504688" y="6053328"/>
-            <a:ext cx="1188720" cy="749808"/>
+            <a:off x="3931920" y="7370064"/>
+            <a:ext cx="2103120" cy="292608"/>
           </a:xfrm>
           <a:prstGeom prst="rect">
             <a:avLst/>
@@ -3976,14 +5447,14 @@
           <a:noFill/>
         </p:spPr>
         <p:txBody>
-          <a:bodyPr wrap="square" anchor="t" lIns="25400" rIns="25400" tIns="12700" bIns="12700">
+          <a:bodyPr wrap="square" anchor="t" lIns="6350" rIns="6350" tIns="6350" bIns="6350">
             <a:spAutoFit/>
           </a:bodyPr>
           <a:lstStyle/>
           <a:p>
             <a:pPr algn="ctr"/>
             <a:r>
-              <a:rPr sz="800" b="0">
+              <a:rPr sz="1000" b="0">
                 <a:solidFill>
                   <a:srgbClr val="000000"/>
                 </a:solidFill>
@@ -3994,52 +5465,16 @@
           </a:p>
         </p:txBody>
       </p:sp>
-      <p:cxnSp>
-        <p:nvCxnSpPr>
-          <p:cNvPr id="27" name="Connector 26"/>
-          <p:cNvCxnSpPr/>
-          <p:nvPr/>
-        </p:nvCxnSpPr>
-        <p:spPr>
-          <a:xfrm flipV="1">
-            <a:off x="7223760" y="4251960"/>
-            <a:ext cx="0" cy="1737360"/>
-          </a:xfrm>
-          <a:prstGeom prst="line">
-            <a:avLst/>
-          </a:prstGeom>
-          <a:ln w="19050">
-            <a:solidFill>
-              <a:srgbClr val="000000"/>
-            </a:solidFill>
-            <a:tailEnd type="triangle" w="med" len="med"/>
-          </a:ln>
-        </p:spPr>
-        <p:style>
-          <a:lnRef idx="2">
-            <a:schemeClr val="accent1"/>
-          </a:lnRef>
-          <a:fillRef idx="0">
-            <a:schemeClr val="accent1"/>
-          </a:fillRef>
-          <a:effectRef idx="1">
-            <a:schemeClr val="accent1"/>
-          </a:effectRef>
-          <a:fontRef idx="minor">
-            <a:schemeClr val="tx1"/>
-          </a:fontRef>
-        </p:style>
-      </p:cxnSp>
-      <p:sp>
-        <p:nvSpPr>
-          <p:cNvPr id="28" name="TextBox 27"/>
+      <p:sp>
+        <p:nvSpPr>
+          <p:cNvPr id="66" name="TextBox 65"/>
           <p:cNvSpPr txBox="1"/>
           <p:nvPr/>
         </p:nvSpPr>
         <p:spPr>
           <a:xfrm>
-            <a:off x="6629400" y="6053328"/>
-            <a:ext cx="1188720" cy="749808"/>
+            <a:off x="6217920" y="7370064"/>
+            <a:ext cx="2377440" cy="292608"/>
           </a:xfrm>
           <a:prstGeom prst="rect">
             <a:avLst/>
@@ -4047,14 +5482,14 @@
           <a:noFill/>
         </p:spPr>
         <p:txBody>
-          <a:bodyPr wrap="square" anchor="t" lIns="25400" rIns="25400" tIns="12700" bIns="12700">
+          <a:bodyPr wrap="square" anchor="t" lIns="6350" rIns="6350" tIns="6350" bIns="6350">
             <a:spAutoFit/>
           </a:bodyPr>
           <a:lstStyle/>
           <a:p>
             <a:pPr algn="ctr"/>
             <a:r>
-              <a:rPr sz="800" b="0">
+              <a:rPr sz="1000" b="0">
                 <a:solidFill>
                   <a:srgbClr val="000000"/>
                 </a:solidFill>

</xml_diff>